<commit_message>
Roteiro cabe em 5 minutos com estimativa conservadora; deck define metricas
- Estimativa de tempo a 135 palavras/min contando numeros como 3 palavras
  faladas (antes: 145 palavras/min, que estourava 5 min num ensaio real)
- Falas reescritas: ~4 min 21 s; contagens longas trocadas por percentuais
- Slide 5 define "poder de previsao"; slide 3 cita a meta estadual; slide 8
  mostra os cenarios tambem em percentual
- Numero de testes e de decisoes lidos do repositorio, nao fixos no codigo

Co-Authored-By: Claude Opus 5.5 <noreply@anthropic.com>
</commit_message>
<xml_diff>
--- a/reports/presentation/Alfabetizacao_Fase3_Apresentacao.pptx
+++ b/reports/presentation/Alfabetizacao_Fase3_Apresentacao.pptx
@@ -1523,7 +1523,7 @@
           <a:lstStyle/>
           <a:p>
             <a:r>
-              <a:t>Olá. Eu sou Felipe Barbato de Biaggio, e este é o Case 3 do Tech Challenge. Vou mostrar como antecipar, antes da prova, quais crianças e quais municípios estão em risco de não se alfabetizar.</a:t>
+              <a:t>Olá, eu sou Felipe Barbato de Biaggio. Neste Case 3, mostro como antecipar, antes da prova, quais crianças e quais municípios estão em risco de não se alfabetizar.</a:t>
             </a:r>
           </a:p>
         </p:txBody>
@@ -1593,7 +1593,7 @@
           <a:lstStyle/>
           <a:p>
             <a:r>
-              <a:t>Resumindo: o histórico educacional é o melhor sinal de risco, contexto desfavorável não é destino, e com o que já sabemos dá para agir antes da prova. Os próximos passos são incluir o Censo Escolar e o CadÚnico, revalidar com os dados de 2025 e fazer um piloto com uma secretaria. Obrigado.</a:t>
+              <a:t>Resumindo: o histórico educacional é o melhor sinal de risco, contexto não é destino, e dá para agir antes da prova. Próximos passos: incluir o Censo Escolar e o CadÚnico, revalidar com os dados de 2025 e fazer um piloto com uma secretaria. Obrigado.</a:t>
             </a:r>
           </a:p>
         </p:txBody>
@@ -1663,7 +1663,7 @@
           <a:lstStyle/>
           <a:p>
             <a:r>
-              <a:t>O Brasil se comprometeu a alfabetizar todas as crianças até o fim do segundo ano, até 2030. O indicador nacional avançou: de 56% em 2023 para 66% em 2025. Mesmo assim, uma em cada três crianças ainda termina o segundo ano sem estar alfabetizada, e quase metade dos municípios ficou abaixo da própria meta em 2024. O problema é de tempo: quando o resultado sai, o ano letivo já acabou. A nossa pergunta foi: com o que já se sabe no início do ano, dá para antecipar onde está o risco?</a:t>
+              <a:t>O Brasil se comprometeu a alfabetizar todas as crianças até o fim do segundo ano, até 2030. O país avançou, de 56 para 66% em dois anos. Mas uma em cada três crianças ainda termina o segundo ano sem estar alfabetizada, e quase metade dos municípios ficou abaixo da própria meta em 2024. E o resultado chega tarde: quando sai, o ano letivo já acabou. A pergunta é: dá para antecipar o risco antes da prova?</a:t>
             </a:r>
           </a:p>
         </p:txBody>
@@ -1733,7 +1733,7 @@
           <a:lstStyle/>
           <a:p>
             <a:r>
-              <a:t>Usamos a base construída na fase anterior, com 1,85 milhão de alunos avaliados em 2024, e treinamos um modelo que estima, para cada aluno, a chance de se alfabetizar. Somando os alunos de um município, temos a taxa esperada, que comparamos com a meta. A regra de ouro: o modelo só usa o que existe antes da prova, como o desempenho do município no ano anterior, a meta, a escola e o IDHM. Nada do resultado que queremos prever.</a:t>
+              <a:t>Com a base da fase anterior, quase dois milhões de alunos, treinamos um modelo que estima a chance de cada criança se alfabetizar. Somando por município, temos a taxa esperada, comparável com a meta. A regra de ouro: o modelo só usa o que existe antes da prova, como o histórico do município, a meta, a escola e o IDHM.</a:t>
             </a:r>
           </a:p>
         </p:txBody>
@@ -1803,7 +1803,7 @@
           <a:lstStyle/>
           <a:p>
             <a:r>
-              <a:t>Por que confiar? Primeiro, testamos o modelo em 1.164 municípios que ele nunca viu. Segundo, comparamos três algoritmos e ficamos com o mais simples entre os empatados, uma regressão logística, que dá para explicar a qualquer gestor. Terceiro, as probabilidades são confiáveis: em 2024, o modelo previu 59,3% de alfabetização no Brasil, e o número oficial foi 59,2%. E tudo é reproduzível: refazendo o projeto do zero, os números saem idênticos.</a:t>
+              <a:t>Por que confiar? Testamos o modelo em mais de mil municípios que ele nunca viu. Entre três algoritmos, ficamos com o mais simples entre os empatados, uma regressão logística, explicável a qualquer gestor. E as probabilidades são confiáveis: para o Brasil em 2024, o modelo previu 59,3%, e o oficial foi 59,2%.</a:t>
             </a:r>
           </a:p>
         </p:txBody>
@@ -1873,7 +1873,7 @@
           <a:lstStyle/>
           <a:p>
             <a:r>
-              <a:t>O principal achado: o que mais pesa no resultado de uma criança é o histórico educacional do município. Só com o histórico do ano anterior, ou seja, a taxa de alfabetização, a proficiência e a participação na prova, o modelo entrega 97% do seu poder de previsão. O IDHM, sozinho, entrega 26%. Para a gestão: as alavancas mais fortes são educacionais, como formação, material e acompanhamento, e respondem em um ano letivo.</a:t>
+              <a:t>O principal achado: o que mais pesa é o histórico educacional do município. Só com a taxa, a proficiência e a participação do ano anterior, o modelo entrega 97% do seu poder de previsão; o IDHM, sozinho, só 26%. Para a gestão: as alavancas mais fortes são educacionais, como formação, material e acompanhamento, e respondem em um ano letivo.</a:t>
             </a:r>
           </a:p>
         </p:txBody>
@@ -1943,7 +1943,7 @@
           <a:lstStyle/>
           <a:p>
             <a:r>
-              <a:t>Agrupamos os municípios em três perfis. O de maior alfabetização não é o mais rico: tem IDHM Educação menor que o perfil intermediário e alfabetiza 21 pontos a mais. O caso mais claro é o Ceará: 93% dos municípios estão nesse perfil, com média de 90% de crianças alfabetizadas. O estado tem programa próprio de alfabetização desde 2007. Contexto desfavorável não é destino, e isso mostra onde buscar práticas para replicar.</a:t>
+              <a:t>E contexto não é destino. O perfil de municípios com maior alfabetização tem IDHM menor que o intermediário, e alfabetiza 21 pontos a mais. O Ceará é o caso mais claro: 93% dos seus municípios estão nesse perfil, e o estado tem programa próprio de alfabetização desde 2007. É ali que vale buscar práticas para replicar.</a:t>
             </a:r>
           </a:p>
         </p:txBody>
@@ -2013,7 +2013,7 @@
           <a:lstStyle/>
           <a:p>
             <a:r>
-              <a:t>Individualmente, o modelo erra bastante: ele não conhece a criança, só o contexto. Mas para priorizar, ele funciona. Se um programa só consegue atender 20% dos alunos, escolhendo pelo modelo ele encontra uma vez e meia mais crianças em risco do que escolhendo ao acaso. E o risco está concentrado: Bahia e Rio Grande do Norte somam 66% dos 50 municípios de maior risco.</a:t>
+              <a:t>Para uma criança específica, o modelo erra bastante: ele vê o contexto, não a criança. Mas para priorizar, ele funciona. Atendendo os 20% indicados pelo modelo, um programa encontra uma vez e meia mais crianças em risco do que escolhendo ao acaso. E o risco está concentrado: Bahia e Rio Grande do Norte somam 66% dos 50 municípios de maior risco.</a:t>
             </a:r>
           </a:p>
         </p:txBody>
@@ -2083,7 +2083,7 @@
           <a:lstStyle/>
           <a:p>
             <a:r>
-              <a:t>Também testamos no passado: com dados de 2023, o modelo apontou os municípios que ficariam abaixo da meta de 2024, e seis em cada dez alertas se confirmaram. Para 2025, tivemos uma validação real: o resultado nacional já saiu, 66%. O modelo projetou 61%: acertou a direção, mas subestimou o avanço. Por isso apresentamos dois cenários: entre 1.757 e 2.382 municípios com risco de ficar abaixo da meta. A ordem de prioridade é a mesma nos dois.</a:t>
+              <a:t>No teste com o passado, seis em cada dez alertas de meta se confirmaram. Para 2025, tivemos uma validação real: o Brasil fez 66%, e o modelo projetou 61%. Acertou a direção, mas subestimou o avanço. Por isso trabalhamos com dois cenários: entre 37% e 50% dos municípios com risco de ficar abaixo da meta, com a mesma ordem de prioridade.</a:t>
             </a:r>
           </a:p>
         </p:txBody>
@@ -2153,7 +2153,7 @@
           <a:lstStyle/>
           <a:p>
             <a:r>
-              <a:t>Como isso apoia a política pública? São três usos. Priorizar municípios antes do ano letivo. Alertar sobre metas, a tempo de pactuar apoio. E monitorar a cada ano, porque a base se atualiza a cada divulgação do INEP. Com um cuidado importante: o modelo indica onde concentrar apoio, nunca quem punir.</a:t>
+              <a:t>Na prática, são três usos: priorizar municípios antes do ano letivo, alertar sobre metas a tempo de pactuar apoio e monitorar a cada ano, já que a base se atualiza a cada divulgação do INEP. Com um cuidado: o modelo indica onde concentrar apoio, nunca quem punir.</a:t>
             </a:r>
           </a:p>
         </p:txBody>
@@ -8356,7 +8356,7 @@
                 </a:solidFill>
                 <a:latin typeface="Calibri"/>
               </a:rPr>
-              <a:t>O estado do aluno: com um ano de treino, aprenderia o choque daquele ano (ex.: enchentes no RS)</a:t>
+              <a:t>O estado do aluno (nem a meta estadual): com um ano de treino, aprenderia o choque daquele ano (ex.: enchentes no RS)</a:t>
             </a:r>
           </a:p>
         </p:txBody>
@@ -9505,7 +9505,7 @@
                 </a:solidFill>
                 <a:latin typeface="Calibri"/>
               </a:rPr>
-              <a:t>Ablação: modelo retreinado só com cada grupo, em validação cruzada agrupada por município.</a:t>
+              <a:t>Poder de previsão = ganho de ROC-AUC sobre o acaso (0,5), relativo ao modelo completo. Ablação: modelo retreinado só com cada grupo, em validação cruzada agrupada por município.</a:t>
             </a:r>
           </a:p>
         </p:txBody>
@@ -12339,7 +12339,42 @@
       </p:sp>
       <p:sp>
         <p:nvSpPr>
-          <p:cNvPr id="18" name="Rounded Rectangle 17"/>
+          <p:cNvPr id="18" name="TextBox 17"/>
+          <p:cNvSpPr txBox="1"/>
+          <p:nvPr/>
+        </p:nvSpPr>
+        <p:spPr>
+          <a:xfrm>
+            <a:off x="8641080" y="3364992"/>
+            <a:ext cx="2971800" cy="292608"/>
+          </a:xfrm>
+          <a:prstGeom prst="rect">
+            <a:avLst/>
+          </a:prstGeom>
+          <a:noFill/>
+        </p:spPr>
+        <p:txBody>
+          <a:bodyPr wrap="square" anchor="t">
+            <a:spAutoFit/>
+          </a:bodyPr>
+          <a:lstStyle/>
+          <a:p>
+            <a:pPr algn="ctr"/>
+            <a:r>
+              <a:rPr sz="1100" b="1" i="0">
+                <a:solidFill>
+                  <a:srgbClr val="C0392B"/>
+                </a:solidFill>
+                <a:latin typeface="Calibri"/>
+              </a:rPr>
+              <a:t>50% dos municípios avaliados</a:t>
+            </a:r>
+          </a:p>
+        </p:txBody>
+      </p:sp>
+      <p:sp>
+        <p:nvSpPr>
+          <p:cNvPr id="19" name="Rounded Rectangle 18"/>
           <p:cNvSpPr/>
           <p:nvPr/>
         </p:nvSpPr>
@@ -12387,7 +12422,7 @@
       </p:sp>
       <p:sp>
         <p:nvSpPr>
-          <p:cNvPr id="19" name="TextBox 18"/>
+          <p:cNvPr id="20" name="TextBox 19"/>
           <p:cNvSpPr txBox="1"/>
           <p:nvPr/>
         </p:nvSpPr>
@@ -12422,7 +12457,7 @@
       </p:sp>
       <p:sp>
         <p:nvSpPr>
-          <p:cNvPr id="20" name="TextBox 19"/>
+          <p:cNvPr id="21" name="TextBox 20"/>
           <p:cNvSpPr txBox="1"/>
           <p:nvPr/>
         </p:nvSpPr>
@@ -12457,7 +12492,7 @@
       </p:sp>
       <p:sp>
         <p:nvSpPr>
-          <p:cNvPr id="21" name="TextBox 20"/>
+          <p:cNvPr id="22" name="TextBox 21"/>
           <p:cNvSpPr txBox="1"/>
           <p:nvPr/>
         </p:nvSpPr>
@@ -12485,14 +12520,14 @@
                 </a:solidFill>
                 <a:latin typeface="Calibri"/>
               </a:rPr>
-              <a:t>de 4.760 · mesma ordem de prioridade</a:t>
-            </a:r>
-          </a:p>
-        </p:txBody>
-      </p:sp>
-      <p:sp>
-        <p:nvSpPr>
-          <p:cNvPr id="22" name="TextBox 21"/>
+              <a:t>37% de 4.760 · mesma prioridade</a:t>
+            </a:r>
+          </a:p>
+        </p:txBody>
+      </p:sp>
+      <p:sp>
+        <p:nvSpPr>
+          <p:cNvPr id="23" name="TextBox 22"/>
           <p:cNvSpPr txBox="1"/>
           <p:nvPr/>
         </p:nvSpPr>

</xml_diff>